<commit_message>
Update presentation with author name and student ID
</commit_message>
<xml_diff>
--- a/Superstore_Sales_Analysis_Presentation.pptx
+++ b/Superstore_Sales_Analysis_Presentation.pptx
@@ -3209,6 +3209,19 @@
             <a:r>
               <a:t>Python • Pandas • Matplotlib/Seaborn • SQL</a:t>
             </a:r>
+          </a:p>
+          <a:p>
+            <a:pPr algn="l"/>
+            <a:r>
+              <a:rPr lang="en-US" sz="1450" b="1">
+                <a:solidFill>
+                  <a:srgbClr val="C8DCF0"/>
+                </a:solidFill>
+                <a:latin typeface="Aptos Display"/>
+              </a:rPr>
+              <a:t>Prepared by: BADAL CHAUDHARY  |  Student ID: STU6a30b8115dd5c1781577745</a:t>
+            </a:r>
+            <a:endParaRPr lang="en-US" sz="1450"/>
           </a:p>
         </p:txBody>
       </p:sp>

</xml_diff>